<commit_message>
Making Fixes In Ui and Credits System
</commit_message>
<xml_diff>
--- a/examples/professional_demo/Financials_AI_PRO_Tier.pptx
+++ b/examples/professional_demo/Financials_AI_PRO_Tier.pptx
@@ -236,22 +236,22 @@
                 <c:formatCode>General</c:formatCode>
                 <c:ptCount val="6"/>
                 <c:pt idx="0">
-                  <c:v>27.8</c:v>
+                  <c:v>33011143.96</c:v>
                 </c:pt>
                 <c:pt idx="1">
-                  <c:v>17.28</c:v>
+                  <c:v>20511921.02</c:v>
                 </c:pt>
                 <c:pt idx="2">
-                  <c:v>15.37</c:v>
+                  <c:v>18250059.47</c:v>
                 </c:pt>
                 <c:pt idx="3">
-                  <c:v>14.95</c:v>
+                  <c:v>17747116.07</c:v>
                 </c:pt>
                 <c:pt idx="4">
-                  <c:v>12.96</c:v>
+                  <c:v>15390801.88</c:v>
                 </c:pt>
                 <c:pt idx="5">
-                  <c:v>11.64</c:v>
+                  <c:v>13815307.89</c:v>
                 </c:pt>
               </c:numCache>
             </c:numRef>
@@ -394,22 +394,22 @@
                 <c:formatCode>General</c:formatCode>
                 <c:ptCount val="6"/>
                 <c:pt idx="0">
-                  <c:v>14.95</c:v>
+                  <c:v>17747116.07</c:v>
                 </c:pt>
                 <c:pt idx="1">
-                  <c:v>11.64</c:v>
+                  <c:v>13815307.89</c:v>
                 </c:pt>
                 <c:pt idx="2">
-                  <c:v>12.96</c:v>
+                  <c:v>15390801.88</c:v>
                 </c:pt>
                 <c:pt idx="3">
-                  <c:v>27.8</c:v>
+                  <c:v>33011143.96</c:v>
                 </c:pt>
                 <c:pt idx="4">
-                  <c:v>17.28</c:v>
+                  <c:v>20511921.02</c:v>
                 </c:pt>
                 <c:pt idx="5">
-                  <c:v>15.37</c:v>
+                  <c:v>18250059.47</c:v>
                 </c:pt>
               </c:numCache>
             </c:numRef>
@@ -616,6 +616,7 @@
 
 <file path=ppt/charts/chart3.xml><?xml version="1.0" encoding="utf-8"?>
 <c:chartSpace xmlns:c="http://schemas.openxmlformats.org/drawingml/2006/chart" xmlns:a="http://schemas.openxmlformats.org/drawingml/2006/main" xmlns:r="http://schemas.openxmlformats.org/officeDocument/2006/relationships">
+  <c:date1904 val="0"/>
   <c:chart>
     <c:title>
       <c:tx>
@@ -627,7 +628,7 @@
               <a:defRPr sz="1600" b="1"/>
             </a:pPr>
             <a:r>
-              <a:t>Category Distribution</a:t>
+              <a:t>Distribution by Sector</a:t>
             </a:r>
           </a:p>
         </c:rich>
@@ -637,8 +638,9 @@
     </c:title>
     <c:autoTitleDeleted val="0"/>
     <c:plotArea>
-      <c:pieChart>
-        <c:varyColors val="1"/>
+      <c:barChart>
+        <c:barDir val="bar"/>
+        <c:grouping val="clustered"/>
         <c:ser>
           <c:idx val="0"/>
           <c:order val="0"/>
@@ -661,12 +663,67 @@
               </a:solidFill>
             </c:spPr>
           </c:dPt>
+          <c:dPt>
+            <c:idx val="1"/>
+            <c:spPr>
+              <a:solidFill>
+                <a:srgbClr val="2E7D32"/>
+              </a:solidFill>
+            </c:spPr>
+          </c:dPt>
+          <c:dPt>
+            <c:idx val="2"/>
+            <c:spPr>
+              <a:solidFill>
+                <a:srgbClr val="FFC107"/>
+              </a:solidFill>
+            </c:spPr>
+          </c:dPt>
+          <c:dPt>
+            <c:idx val="3"/>
+            <c:spPr>
+              <a:solidFill>
+                <a:srgbClr val="D32F2F"/>
+              </a:solidFill>
+            </c:spPr>
+          </c:dPt>
+          <c:dPt>
+            <c:idx val="4"/>
+            <c:spPr>
+              <a:solidFill>
+                <a:srgbClr val="9C27B0"/>
+              </a:solidFill>
+            </c:spPr>
+          </c:dPt>
+          <c:dPt>
+            <c:idx val="5"/>
+            <c:spPr>
+              <a:solidFill>
+                <a:srgbClr val="FF9800"/>
+              </a:solidFill>
+            </c:spPr>
+          </c:dPt>
           <c:cat>
             <c:strRef>
-              <c:f>Sheet1!$A$2:$A$2</c:f>
+              <c:f>Sheet1!$A$2:$A$7</c:f>
               <c:strCache>
-                <c:ptCount val="1"/>
+                <c:ptCount val="6"/>
                 <c:pt idx="0">
+                  <c:v>Consumer Goods</c:v>
+                </c:pt>
+                <c:pt idx="1">
+                  <c:v>Consumer Goods</c:v>
+                </c:pt>
+                <c:pt idx="2">
+                  <c:v>Consumer Goods</c:v>
+                </c:pt>
+                <c:pt idx="3">
+                  <c:v>Consumer Goods</c:v>
+                </c:pt>
+                <c:pt idx="4">
+                  <c:v>Consumer Goods</c:v>
+                </c:pt>
+                <c:pt idx="5">
                   <c:v>Consumer Goods</c:v>
                 </c:pt>
               </c:strCache>
@@ -674,31 +731,76 @@
           </c:cat>
           <c:val>
             <c:numRef>
-              <c:f>Sheet1!$B$2:$B$2</c:f>
+              <c:f>Sheet1!$B$2:$B$7</c:f>
               <c:numCache>
                 <c:formatCode>General</c:formatCode>
-                <c:ptCount val="1"/>
+                <c:ptCount val="6"/>
                 <c:pt idx="0">
-                  <c:v>6</c:v>
+                  <c:v>33011143.96</c:v>
+                </c:pt>
+                <c:pt idx="1">
+                  <c:v>20511921.02</c:v>
+                </c:pt>
+                <c:pt idx="2">
+                  <c:v>18250059.47</c:v>
+                </c:pt>
+                <c:pt idx="3">
+                  <c:v>17747116.07</c:v>
+                </c:pt>
+                <c:pt idx="4">
+                  <c:v>15390801.88</c:v>
+                </c:pt>
+                <c:pt idx="5">
+                  <c:v>13815307.89</c:v>
                 </c:pt>
               </c:numCache>
             </c:numRef>
           </c:val>
         </c:ser>
-        <c:dLbls>
-          <c:showLegendKey val="0"/>
-          <c:showVal val="1"/>
-          <c:showCatName val="1"/>
-          <c:showSerName val="0"/>
-          <c:showPercent val="1"/>
-          <c:showBubbleSize val="0"/>
-          <c:showLeaderLines val="1"/>
-        </c:dLbls>
-      </c:pieChart>
+        <c:axId val="-2068027336"/>
+        <c:axId val="-2113994440"/>
+      </c:barChart>
+      <c:catAx>
+        <c:axId val="-2068027336"/>
+        <c:scaling>
+          <c:orientation val="minMax"/>
+        </c:scaling>
+        <c:delete val="0"/>
+        <c:axPos val="l"/>
+        <c:majorTickMark val="out"/>
+        <c:minorTickMark val="none"/>
+        <c:tickLblPos val="nextTo"/>
+        <c:crossAx val="-2113994440"/>
+        <c:crosses val="autoZero"/>
+        <c:auto val="1"/>
+        <c:lblAlgn val="ctr"/>
+        <c:lblOffset val="100"/>
+        <c:noMultiLvlLbl val="0"/>
+      </c:catAx>
+      <c:valAx>
+        <c:axId val="-2113994440"/>
+        <c:scaling/>
+        <c:delete val="0"/>
+        <c:axPos val="b"/>
+        <c:majorGridlines/>
+        <c:majorTickMark val="out"/>
+        <c:minorTickMark val="none"/>
+        <c:tickLblPos val="nextTo"/>
+        <c:crossAx val="-2068027336"/>
+        <c:crosses val="autoZero"/>
+      </c:valAx>
     </c:plotArea>
     <c:legend>
       <c:legendPos/>
-      <c:overlay val="0"/>
+      <c:txPr>
+        <a:bodyPr/>
+        <a:lstStyle/>
+        <a:p>
+          <a:pPr>
+            <a:defRPr sz="900"/>
+          </a:pPr>
+        </a:p>
+      </c:txPr>
     </c:legend>
     <c:dispBlanksAs val="gap"/>
   </c:chart>
@@ -4005,7 +4107,7 @@
               </a:defRPr>
             </a:pPr>
             <a:r>
-              <a:t>✓  Paseo  leads with $27.80 in MarketCap</a:t>
+              <a:t>✓  Paseo  leads with $33.01M in MarketCap</a:t>
             </a:r>
           </a:p>
           <a:p>
@@ -4192,7 +4294,7 @@
               </a:defRPr>
             </a:pPr>
             <a:r>
-              <a:t>Total Market Cap</a:t>
+              <a:t>Total Market Cap (Millions)</a:t>
             </a:r>
           </a:p>
         </p:txBody>
@@ -4227,7 +4329,7 @@
               </a:defRPr>
             </a:pPr>
             <a:r>
-              <a:t>$0.0B</a:t>
+              <a:t>$118.73M</a:t>
             </a:r>
           </a:p>
         </p:txBody>
@@ -4926,7 +5028,7 @@
               </a:defRPr>
             </a:pPr>
             <a:r>
-              <a:t>💡 Key Insight: Consumer Goods is the sole category, encompassing 100% of the breakdown.</a:t>
+              <a:t>💡 Key Insight: Consumer Goods: 6 out of 6 entities (100.0%)</a:t>
             </a:r>
           </a:p>
         </p:txBody>
@@ -5573,7 +5675,7 @@
               </a:defRPr>
             </a:pPr>
             <a:r>
-              <a:t>💼 AI Insights &amp; Market Predictions</a:t>
+              <a:t>� Key Data Insights</a:t>
             </a:r>
           </a:p>
         </p:txBody>
@@ -5587,60 +5689,17 @@
         <p:spPr>
           <a:xfrm>
             <a:off x="731520" y="1371600"/>
-            <a:ext cx="137160" cy="1371600"/>
+            <a:ext cx="7680960" cy="4572000"/>
           </a:xfrm>
           <a:prstGeom prst="rect">
             <a:avLst/>
           </a:prstGeom>
           <a:solidFill>
-            <a:srgbClr val="2E7D32"/>
+            <a:srgbClr val="F8F9FA"/>
           </a:solidFill>
-          <a:ln>
-            <a:noFill/>
-          </a:ln>
-        </p:spPr>
-        <p:style>
-          <a:lnRef idx="1">
-            <a:schemeClr val="accent1"/>
-          </a:lnRef>
-          <a:fillRef idx="3">
-            <a:schemeClr val="accent1"/>
-          </a:fillRef>
-          <a:effectRef idx="2">
-            <a:schemeClr val="accent1"/>
-          </a:effectRef>
-          <a:fontRef idx="minor">
-            <a:schemeClr val="lt1"/>
-          </a:fontRef>
-        </p:style>
-        <p:txBody>
-          <a:bodyPr rtlCol="0" anchor="ctr"/>
-          <a:lstStyle/>
-          <a:p>
-            <a:pPr algn="ctr"/>
-          </a:p>
-        </p:txBody>
-      </p:sp>
-      <p:sp>
-        <p:nvSpPr>
-          <p:cNvPr id="4" name="Rectangle 3"/>
-          <p:cNvSpPr/>
-          <p:nvPr/>
-        </p:nvSpPr>
-        <p:spPr>
-          <a:xfrm>
-            <a:off x="914400" y="1371600"/>
-            <a:ext cx="7315200" cy="1371600"/>
-          </a:xfrm>
-          <a:prstGeom prst="rect">
-            <a:avLst/>
-          </a:prstGeom>
-          <a:solidFill>
-            <a:srgbClr val="FAFAFA"/>
-          </a:solidFill>
-          <a:ln w="12700">
+          <a:ln w="25400">
             <a:solidFill>
-              <a:srgbClr val="DCDCDC"/>
+              <a:srgbClr val="2196F3"/>
             </a:solidFill>
           </a:ln>
         </p:spPr>
@@ -5668,14 +5727,14 @@
       </p:sp>
       <p:sp>
         <p:nvSpPr>
-          <p:cNvPr id="5" name="TextBox 4"/>
+          <p:cNvPr id="4" name="TextBox 3"/>
           <p:cNvSpPr txBox="1"/>
           <p:nvPr/>
         </p:nvSpPr>
         <p:spPr>
           <a:xfrm>
-            <a:off x="1097280" y="1463040"/>
-            <a:ext cx="6858000" cy="365760"/>
+            <a:off x="1097280" y="1828800"/>
+            <a:ext cx="6949440" cy="3840480"/>
           </a:xfrm>
           <a:prstGeom prst="rect">
             <a:avLst/>
@@ -5683,419 +5742,74 @@
           <a:noFill/>
         </p:spPr>
         <p:txBody>
-          <a:bodyPr wrap="none">
+          <a:bodyPr wrap="square" lIns="182880">
             <a:spAutoFit/>
           </a:bodyPr>
           <a:lstStyle/>
           <a:p>
             <a:pPr>
-              <a:defRPr sz="2200" b="1">
+              <a:lnSpc>
+                <a:spcPct val="130000"/>
+              </a:lnSpc>
+              <a:spcBef>
+                <a:spcPts val="500"/>
+              </a:spcBef>
+              <a:spcAft>
+                <a:spcPts val="1200"/>
+              </a:spcAft>
+              <a:defRPr sz="1600">
                 <a:solidFill>
-                  <a:srgbClr val="2E7D32"/>
+                  <a:srgbClr val="343A40"/>
                 </a:solidFill>
+                <a:latin typeface="Calibri"/>
               </a:defRPr>
             </a:pPr>
             <a:r>
-              <a:t>📈 Top 3 Performers</a:t>
-            </a:r>
-          </a:p>
-        </p:txBody>
-      </p:sp>
-      <p:sp>
-        <p:nvSpPr>
-          <p:cNvPr id="6" name="TextBox 5"/>
-          <p:cNvSpPr txBox="1"/>
-          <p:nvPr/>
-        </p:nvSpPr>
-        <p:spPr>
-          <a:xfrm>
-            <a:off x="1280160" y="1828800"/>
-            <a:ext cx="6675120" cy="822960"/>
-          </a:xfrm>
-          <a:prstGeom prst="rect">
-            <a:avLst/>
-          </a:prstGeom>
-          <a:noFill/>
-        </p:spPr>
-        <p:txBody>
-          <a:bodyPr wrap="square">
-            <a:spAutoFit/>
-          </a:bodyPr>
-          <a:lstStyle/>
+              <a:t>✓  Amarilla  showed strong momentum with 16.5% annual return and $17.75M market cap, demonstrating solid investor confidence.</a:t>
+            </a:r>
+          </a:p>
           <a:p>
             <a:pPr>
               <a:lnSpc>
-                <a:spcPct val="120000"/>
+                <a:spcPct val="130000"/>
               </a:lnSpc>
+              <a:spcBef>
+                <a:spcPts val="500"/>
+              </a:spcBef>
               <a:spcAft>
-                <a:spcPts val="300"/>
+                <a:spcPts val="1200"/>
               </a:spcAft>
-              <a:defRPr sz="1400"/>
+              <a:defRPr sz="1600">
+                <a:solidFill>
+                  <a:srgbClr val="343A40"/>
+                </a:solidFill>
+                <a:latin typeface="Calibri"/>
+              </a:defRPr>
             </a:pPr>
             <a:r>
-              <a:t>→ Data analysis in progress</a:t>
+              <a:t>✓  VTT  showed strong momentum with 15.4% annual return and $20.51M market cap, demonstrating solid investor confidence.</a:t>
             </a:r>
           </a:p>
           <a:p>
             <a:pPr>
               <a:lnSpc>
-                <a:spcPct val="120000"/>
+                <a:spcPct val="130000"/>
               </a:lnSpc>
+              <a:spcBef>
+                <a:spcPts val="500"/>
+              </a:spcBef>
               <a:spcAft>
-                <a:spcPts val="300"/>
+                <a:spcPts val="1200"/>
               </a:spcAft>
-              <a:defRPr sz="1400"/>
-            </a:pPr>
-            <a:r>
-              <a:t>→ Performance metrics being calculated</a:t>
-            </a:r>
-          </a:p>
-          <a:p>
-            <a:pPr>
-              <a:lnSpc>
-                <a:spcPct val="120000"/>
-              </a:lnSpc>
-              <a:spcAft>
-                <a:spcPts val="300"/>
-              </a:spcAft>
-              <a:defRPr sz="1400"/>
-            </a:pPr>
-            <a:r>
-              <a:t>→ Trends under evaluation</a:t>
-            </a:r>
-          </a:p>
-        </p:txBody>
-      </p:sp>
-      <p:sp>
-        <p:nvSpPr>
-          <p:cNvPr id="7" name="Rectangle 6"/>
-          <p:cNvSpPr/>
-          <p:nvPr/>
-        </p:nvSpPr>
-        <p:spPr>
-          <a:xfrm>
-            <a:off x="731520" y="3017520"/>
-            <a:ext cx="137160" cy="1371600"/>
-          </a:xfrm>
-          <a:prstGeom prst="rect">
-            <a:avLst/>
-          </a:prstGeom>
-          <a:solidFill>
-            <a:srgbClr val="E65100"/>
-          </a:solidFill>
-          <a:ln>
-            <a:noFill/>
-          </a:ln>
-        </p:spPr>
-        <p:style>
-          <a:lnRef idx="1">
-            <a:schemeClr val="accent1"/>
-          </a:lnRef>
-          <a:fillRef idx="3">
-            <a:schemeClr val="accent1"/>
-          </a:fillRef>
-          <a:effectRef idx="2">
-            <a:schemeClr val="accent1"/>
-          </a:effectRef>
-          <a:fontRef idx="minor">
-            <a:schemeClr val="lt1"/>
-          </a:fontRef>
-        </p:style>
-        <p:txBody>
-          <a:bodyPr rtlCol="0" anchor="ctr"/>
-          <a:lstStyle/>
-          <a:p>
-            <a:pPr algn="ctr"/>
-          </a:p>
-        </p:txBody>
-      </p:sp>
-      <p:sp>
-        <p:nvSpPr>
-          <p:cNvPr id="8" name="Rectangle 7"/>
-          <p:cNvSpPr/>
-          <p:nvPr/>
-        </p:nvSpPr>
-        <p:spPr>
-          <a:xfrm>
-            <a:off x="914400" y="3017520"/>
-            <a:ext cx="7315200" cy="1371600"/>
-          </a:xfrm>
-          <a:prstGeom prst="rect">
-            <a:avLst/>
-          </a:prstGeom>
-          <a:solidFill>
-            <a:srgbClr val="FAFAFA"/>
-          </a:solidFill>
-          <a:ln w="12700">
-            <a:solidFill>
-              <a:srgbClr val="DCDCDC"/>
-            </a:solidFill>
-          </a:ln>
-        </p:spPr>
-        <p:style>
-          <a:lnRef idx="1">
-            <a:schemeClr val="accent1"/>
-          </a:lnRef>
-          <a:fillRef idx="3">
-            <a:schemeClr val="accent1"/>
-          </a:fillRef>
-          <a:effectRef idx="2">
-            <a:schemeClr val="accent1"/>
-          </a:effectRef>
-          <a:fontRef idx="minor">
-            <a:schemeClr val="lt1"/>
-          </a:fontRef>
-        </p:style>
-        <p:txBody>
-          <a:bodyPr rtlCol="0" anchor="ctr"/>
-          <a:lstStyle/>
-          <a:p>
-            <a:pPr algn="ctr"/>
-          </a:p>
-        </p:txBody>
-      </p:sp>
-      <p:sp>
-        <p:nvSpPr>
-          <p:cNvPr id="9" name="TextBox 8"/>
-          <p:cNvSpPr txBox="1"/>
-          <p:nvPr/>
-        </p:nvSpPr>
-        <p:spPr>
-          <a:xfrm>
-            <a:off x="1097280" y="3108960"/>
-            <a:ext cx="6858000" cy="365760"/>
-          </a:xfrm>
-          <a:prstGeom prst="rect">
-            <a:avLst/>
-          </a:prstGeom>
-          <a:noFill/>
-        </p:spPr>
-        <p:txBody>
-          <a:bodyPr wrap="none">
-            <a:spAutoFit/>
-          </a:bodyPr>
-          <a:lstStyle/>
-          <a:p>
-            <a:pPr>
-              <a:defRPr sz="2200" b="1">
+              <a:defRPr sz="1600">
                 <a:solidFill>
-                  <a:srgbClr val="E65100"/>
+                  <a:srgbClr val="343A40"/>
                 </a:solidFill>
+                <a:latin typeface="Calibri"/>
               </a:defRPr>
             </a:pPr>
             <a:r>
-              <a:t>⚠️ Anomalies Detected</a:t>
-            </a:r>
-          </a:p>
-        </p:txBody>
-      </p:sp>
-      <p:sp>
-        <p:nvSpPr>
-          <p:cNvPr id="10" name="TextBox 9"/>
-          <p:cNvSpPr txBox="1"/>
-          <p:nvPr/>
-        </p:nvSpPr>
-        <p:spPr>
-          <a:xfrm>
-            <a:off x="1280160" y="3474720"/>
-            <a:ext cx="6675120" cy="822960"/>
-          </a:xfrm>
-          <a:prstGeom prst="rect">
-            <a:avLst/>
-          </a:prstGeom>
-          <a:noFill/>
-        </p:spPr>
-        <p:txBody>
-          <a:bodyPr wrap="square">
-            <a:spAutoFit/>
-          </a:bodyPr>
-          <a:lstStyle/>
-          <a:p>
-            <a:pPr>
-              <a:lnSpc>
-                <a:spcPct val="120000"/>
-              </a:lnSpc>
-              <a:spcAft>
-                <a:spcPts val="300"/>
-              </a:spcAft>
-              <a:defRPr sz="1400"/>
-            </a:pPr>
-            <a:r>
-              <a:t>→ No significant anomalies detected in current dataset</a:t>
-            </a:r>
-          </a:p>
-        </p:txBody>
-      </p:sp>
-      <p:sp>
-        <p:nvSpPr>
-          <p:cNvPr id="11" name="Rectangle 10"/>
-          <p:cNvSpPr/>
-          <p:nvPr/>
-        </p:nvSpPr>
-        <p:spPr>
-          <a:xfrm>
-            <a:off x="731520" y="4663440"/>
-            <a:ext cx="137160" cy="1371600"/>
-          </a:xfrm>
-          <a:prstGeom prst="rect">
-            <a:avLst/>
-          </a:prstGeom>
-          <a:solidFill>
-            <a:srgbClr val="1976D2"/>
-          </a:solidFill>
-          <a:ln>
-            <a:noFill/>
-          </a:ln>
-        </p:spPr>
-        <p:style>
-          <a:lnRef idx="1">
-            <a:schemeClr val="accent1"/>
-          </a:lnRef>
-          <a:fillRef idx="3">
-            <a:schemeClr val="accent1"/>
-          </a:fillRef>
-          <a:effectRef idx="2">
-            <a:schemeClr val="accent1"/>
-          </a:effectRef>
-          <a:fontRef idx="minor">
-            <a:schemeClr val="lt1"/>
-          </a:fontRef>
-        </p:style>
-        <p:txBody>
-          <a:bodyPr rtlCol="0" anchor="ctr"/>
-          <a:lstStyle/>
-          <a:p>
-            <a:pPr algn="ctr"/>
-          </a:p>
-        </p:txBody>
-      </p:sp>
-      <p:sp>
-        <p:nvSpPr>
-          <p:cNvPr id="12" name="Rectangle 11"/>
-          <p:cNvSpPr/>
-          <p:nvPr/>
-        </p:nvSpPr>
-        <p:spPr>
-          <a:xfrm>
-            <a:off x="914400" y="4663440"/>
-            <a:ext cx="7315200" cy="1371600"/>
-          </a:xfrm>
-          <a:prstGeom prst="rect">
-            <a:avLst/>
-          </a:prstGeom>
-          <a:solidFill>
-            <a:srgbClr val="FAFAFA"/>
-          </a:solidFill>
-          <a:ln w="12700">
-            <a:solidFill>
-              <a:srgbClr val="DCDCDC"/>
-            </a:solidFill>
-          </a:ln>
-        </p:spPr>
-        <p:style>
-          <a:lnRef idx="1">
-            <a:schemeClr val="accent1"/>
-          </a:lnRef>
-          <a:fillRef idx="3">
-            <a:schemeClr val="accent1"/>
-          </a:fillRef>
-          <a:effectRef idx="2">
-            <a:schemeClr val="accent1"/>
-          </a:effectRef>
-          <a:fontRef idx="minor">
-            <a:schemeClr val="lt1"/>
-          </a:fontRef>
-        </p:style>
-        <p:txBody>
-          <a:bodyPr rtlCol="0" anchor="ctr"/>
-          <a:lstStyle/>
-          <a:p>
-            <a:pPr algn="ctr"/>
-          </a:p>
-        </p:txBody>
-      </p:sp>
-      <p:sp>
-        <p:nvSpPr>
-          <p:cNvPr id="13" name="TextBox 12"/>
-          <p:cNvSpPr txBox="1"/>
-          <p:nvPr/>
-        </p:nvSpPr>
-        <p:spPr>
-          <a:xfrm>
-            <a:off x="1097280" y="4754880"/>
-            <a:ext cx="6858000" cy="365760"/>
-          </a:xfrm>
-          <a:prstGeom prst="rect">
-            <a:avLst/>
-          </a:prstGeom>
-          <a:noFill/>
-        </p:spPr>
-        <p:txBody>
-          <a:bodyPr wrap="none">
-            <a:spAutoFit/>
-          </a:bodyPr>
-          <a:lstStyle/>
-          <a:p>
-            <a:pPr>
-              <a:defRPr sz="2200" b="1">
-                <a:solidFill>
-                  <a:srgbClr val="1976D2"/>
-                </a:solidFill>
-              </a:defRPr>
-            </a:pPr>
-            <a:r>
-              <a:t>💡 Predicted Trends</a:t>
-            </a:r>
-          </a:p>
-        </p:txBody>
-      </p:sp>
-      <p:sp>
-        <p:nvSpPr>
-          <p:cNvPr id="14" name="TextBox 13"/>
-          <p:cNvSpPr txBox="1"/>
-          <p:nvPr/>
-        </p:nvSpPr>
-        <p:spPr>
-          <a:xfrm>
-            <a:off x="1280160" y="5120640"/>
-            <a:ext cx="6675120" cy="822960"/>
-          </a:xfrm>
-          <a:prstGeom prst="rect">
-            <a:avLst/>
-          </a:prstGeom>
-          <a:noFill/>
-        </p:spPr>
-        <p:txBody>
-          <a:bodyPr wrap="square">
-            <a:spAutoFit/>
-          </a:bodyPr>
-          <a:lstStyle/>
-          <a:p>
-            <a:pPr>
-              <a:lnSpc>
-                <a:spcPct val="120000"/>
-              </a:lnSpc>
-              <a:spcAft>
-                <a:spcPts val="300"/>
-              </a:spcAft>
-              <a:defRPr sz="1400"/>
-            </a:pPr>
-            <a:r>
-              <a:t>→ Insufficient historical data for accurate predictions</a:t>
-            </a:r>
-          </a:p>
-          <a:p>
-            <a:pPr>
-              <a:lnSpc>
-                <a:spcPct val="120000"/>
-              </a:lnSpc>
-              <a:spcAft>
-                <a:spcPts val="300"/>
-              </a:spcAft>
-              <a:defRPr sz="1400"/>
-            </a:pPr>
-            <a:r>
-              <a:t>→ Continued monitoring recommended</a:t>
+              <a:t>✓  Carretera  showed strong momentum with 14.9% annual return and $13.82M market cap, demonstrating solid investor confidence.</a:t>
             </a:r>
           </a:p>
         </p:txBody>

</xml_diff>